<commit_message>
minor updates to several slides
</commit_message>
<xml_diff>
--- a/PowerPoints/08 - Abstract Syntax Trees.pptx
+++ b/PowerPoints/08 - Abstract Syntax Trees.pptx
@@ -48,7 +48,7 @@
     <p:sldId id="333" r:id="rId36"/>
     <p:sldId id="366" r:id="rId37"/>
     <p:sldId id="311" r:id="rId38"/>
-    <p:sldId id="312" r:id="rId39"/>
+    <p:sldId id="380" r:id="rId39"/>
     <p:sldId id="313" r:id="rId40"/>
     <p:sldId id="328" r:id="rId41"/>
     <p:sldId id="326" r:id="rId42"/>
@@ -8080,35 +8080,13 @@
           <a:p>
             <a:r>
               <a:rPr lang="en-US" dirty="0"/>
-              <a:t>All AST classes will be defined in </a:t>
-            </a:r>
-            <a:r>
-              <a:rPr lang="en-US"/>
-              <a:t>package </a:t>
-            </a:r>
-            <a:r>
-              <a:rPr lang="en-US">
-                <a:latin typeface="Consolas" pitchFamily="49" charset="0"/>
-              </a:rPr>
-              <a:t>edu</a:t>
+              <a:t>All AST classes will be defined in package </a:t>
             </a:r>
             <a:r>
               <a:rPr lang="en-US" dirty="0" err="1">
                 <a:latin typeface="Consolas" pitchFamily="49" charset="0"/>
               </a:rPr>
-              <a:t>.citadel.cprl</a:t>
-            </a:r>
-            <a:r>
-              <a:rPr lang="en-US" err="1">
-                <a:latin typeface="Consolas" pitchFamily="49" charset="0"/>
-              </a:rPr>
-              <a:t>.</a:t>
-            </a:r>
-            <a:r>
-              <a:rPr lang="en-US">
-                <a:latin typeface="Consolas" pitchFamily="49" charset="0"/>
-              </a:rPr>
-              <a:t>ast</a:t>
+              <a:t>edu.citadel.cprl.ast</a:t>
             </a:r>
             <a:r>
               <a:rPr lang="en-US" dirty="0"/>
@@ -8127,7 +8105,7 @@
         </p:nvSpPr>
         <p:spPr bwMode="auto">
           <a:xfrm>
-            <a:off x="1428750" y="4590229"/>
+            <a:off x="1428750" y="4514029"/>
             <a:ext cx="6286500" cy="1200971"/>
           </a:xfrm>
           <a:prstGeom prst="rect">
@@ -8406,7 +8384,19 @@
               <a:rPr lang="en-US" sz="1800" dirty="0">
                 <a:latin typeface="Consolas" pitchFamily="49" charset="0"/>
               </a:rPr>
-              <a:t>    public abstract void checkConstraints();</a:t>
+              <a:t>    public abstract void </a:t>
+            </a:r>
+            <a:r>
+              <a:rPr lang="en-US" sz="1800" dirty="0" err="1">
+                <a:latin typeface="Consolas" pitchFamily="49" charset="0"/>
+              </a:rPr>
+              <a:t>checkConstraints</a:t>
+            </a:r>
+            <a:r>
+              <a:rPr lang="en-US" sz="1800" dirty="0">
+                <a:latin typeface="Consolas" pitchFamily="49" charset="0"/>
+              </a:rPr>
+              <a:t>() ...</a:t>
             </a:r>
           </a:p>
           <a:p>
@@ -8490,7 +8480,7 @@
               <a:rPr lang="en-US" sz="1800" dirty="0">
                 <a:latin typeface="Consolas" pitchFamily="49" charset="0"/>
               </a:rPr>
-              <a:t>;</a:t>
+              <a:t> ...</a:t>
             </a:r>
           </a:p>
           <a:p>
@@ -13428,17 +13418,21 @@
             <a:pPr algn="l"/>
             <a:r>
               <a:rPr lang="en-US" sz="2000" dirty="0"/>
-              <a:t>three values – GLOBAL, </a:t>
-            </a:r>
-            <a:r>
-              <a:rPr lang="en-US" sz="2000" dirty="0">
+              <a:t>three values – GLOBAL</a:t>
+            </a:r>
+            <a:r>
+              <a:rPr lang="en-US" sz="2000"/>
+              <a:t>, </a:t>
+            </a:r>
+            <a:r>
+              <a:rPr lang="en-US" sz="2000">
                 <a:latin typeface="Consolas" panose="020B0609020204030204" pitchFamily="49" charset="0"/>
               </a:rPr>
               <a:t>LOCAL</a:t>
             </a:r>
             <a:r>
-              <a:rPr lang="en-US" sz="2000" dirty="0"/>
-              <a:t> and </a:t>
+              <a:rPr lang="en-US" sz="2000"/>
+              <a:t>, and </a:t>
             </a:r>
             <a:r>
               <a:rPr lang="en-US" sz="2000" dirty="0">
@@ -19596,13 +19590,13 @@
           <a:p>
             <a:r>
               <a:rPr lang="en-US" dirty="0"/>
-              <a:t>When an identifier is encountered in a context other than its declaration (e.g., as part of an expression or subprogram call), the parser will check that the identifier has been declared.</a:t>
-            </a:r>
-          </a:p>
-          <a:p>
-            <a:r>
-              <a:rPr lang="en-US" dirty="0"/>
-              <a:t>The parser will then use the information about how the identifier was declared to facilitate correct parsing (e.g., you can’t assign a value to an identifier that was declared as a constant).</a:t>
+              <a:t>When an identifier is encountered in a context other than its declaration (e.g., as part of an expression or subprogram call), the parser will check to see if the identifier has been declared.</a:t>
+            </a:r>
+          </a:p>
+          <a:p>
+            <a:r>
+              <a:rPr lang="en-US" dirty="0"/>
+              <a:t>If it has, the parser will then use the information about how the identifier was declared to facilitate correct parsing (e.g., you can’t assign a value to an identifier that was declared as a constant).</a:t>
             </a:r>
           </a:p>
         </p:txBody>
@@ -19610,7 +19604,7 @@
     </p:spTree>
     <p:extLst>
       <p:ext uri="{BB962C8B-B14F-4D97-AF65-F5344CB8AC3E}">
-        <p14:creationId xmlns:p14="http://schemas.microsoft.com/office/powerpoint/2010/main" val="338823142"/>
+        <p14:creationId xmlns:p14="http://schemas.microsoft.com/office/powerpoint/2010/main" val="339285903"/>
       </p:ext>
     </p:extLst>
   </p:cSld>
@@ -24741,7 +24735,29 @@
             <a:pPr lvl="1"/>
             <a:r>
               <a:rPr lang="en-US" dirty="0"/>
-              <a:t>do not correspond to the edges of the “tree”.</a:t>
+              <a:t>do not correspond to the edges of the “tree”</a:t>
+            </a:r>
+          </a:p>
+          <a:p>
+            <a:pPr lvl="1"/>
+            <a:r>
+              <a:rPr lang="en-US" dirty="0"/>
+              <a:t>assist with constraint analysis and/or </a:t>
+            </a:r>
+            <a:r>
+              <a:rPr lang="en-US"/>
+              <a:t>code generation but are</a:t>
+            </a:r>
+            <a:br>
+              <a:rPr lang="en-US"/>
+            </a:br>
+            <a:r>
+              <a:rPr lang="en-US"/>
+              <a:t>not </a:t>
+            </a:r>
+            <a:r>
+              <a:rPr lang="en-US" dirty="0"/>
+              <a:t>suggested or motivated by the context-free grammar</a:t>
             </a:r>
           </a:p>
           <a:p>
@@ -28800,7 +28816,15 @@
           <a:p>
             <a:r>
               <a:rPr lang="en-US" dirty="0"/>
-              <a:t>Once a loop statement has been parsed, we don’t need to retain the terminal symbols.  The AST for a loop statement would contain only the statements in the body of the loop and the optional boolean expression (e.g., the reference to the boolean expression could be null).</a:t>
+              <a:t>Once a loop statement has been parsed, we don’t need to retain the terminal symbols.  The AST for a loop statement would contain only </a:t>
+            </a:r>
+            <a:r>
+              <a:rPr lang="en-US"/>
+              <a:t>the statement </a:t>
+            </a:r>
+            <a:r>
+              <a:rPr lang="en-US" dirty="0"/>
+              <a:t>in the body of the loop and the optional boolean expression (e.g., the reference to the boolean expression could be null).</a:t>
             </a:r>
           </a:p>
           <a:p>
@@ -33035,7 +33059,7 @@
         <p:spPr>
           <a:xfrm>
             <a:off x="855278" y="3505200"/>
-            <a:ext cx="7433445" cy="2554545"/>
+            <a:ext cx="7250703" cy="2554545"/>
           </a:xfrm>
           <a:prstGeom prst="rect">
             <a:avLst/>
@@ -33153,24 +33177,18 @@
             </a:r>
             <a:r>
               <a:rPr lang="en-US" sz="2000" dirty="0"/>
-              <a:t> provides </a:t>
-            </a:r>
-            <a:r>
-              <a:rPr lang="en-US" sz="2000" dirty="0">
-                <a:latin typeface="Consolas" panose="020B0609020204030204" pitchFamily="49" charset="0"/>
-              </a:rPr>
-              <a:t>set…</a:t>
+              <a:t> allows the parser to assign values to</a:t>
+            </a:r>
+            <a:br>
+              <a:rPr lang="en-US" sz="2000"/>
+            </a:br>
+            <a:r>
+              <a:rPr lang="en-US" sz="2000"/>
+              <a:t>these two </a:t>
             </a:r>
             <a:r>
               <a:rPr lang="en-US" sz="2000" dirty="0"/>
-              <a:t> methods that the parser uses</a:t>
-            </a:r>
-            <a:br>
-              <a:rPr lang="en-US" sz="2000" dirty="0"/>
-            </a:br>
-            <a:r>
-              <a:rPr lang="en-US" sz="2000" dirty="0"/>
-              <a:t>to assign values to these two fields during parsing.</a:t>
+              <a:t>fields during parsing.</a:t>
             </a:r>
           </a:p>
         </p:txBody>

</xml_diff>